<commit_message>
design: upgrade app and ppt presentation visibility for hackathon booth
</commit_message>
<xml_diff>
--- a/VeloRoute_Vientiane_Presentation.pptx
+++ b/VeloRoute_Vientiane_Presentation.pptx
@@ -3105,14 +3105,59 @@
       <p:grpSpPr/>
       <p:sp>
         <p:nvSpPr>
-          <p:cNvPr id="2" name="TextBox 1"/>
+          <p:cNvPr id="2" name="Rounded Rectangle 1"/>
+          <p:cNvSpPr/>
+          <p:nvPr/>
+        </p:nvSpPr>
+        <p:spPr>
+          <a:xfrm>
+            <a:off x="731520" y="1097280"/>
+            <a:ext cx="10728655" cy="4663440"/>
+          </a:xfrm>
+          <a:prstGeom prst="roundRect">
+            <a:avLst/>
+          </a:prstGeom>
+          <a:solidFill>
+            <a:srgbClr val="151D2B"/>
+          </a:solidFill>
+          <a:ln w="25400">
+            <a:solidFill>
+              <a:srgbClr val="60A5FA"/>
+            </a:solidFill>
+          </a:ln>
+        </p:spPr>
+        <p:style>
+          <a:lnRef idx="1">
+            <a:schemeClr val="accent1"/>
+          </a:lnRef>
+          <a:fillRef idx="3">
+            <a:schemeClr val="accent1"/>
+          </a:fillRef>
+          <a:effectRef idx="2">
+            <a:schemeClr val="accent1"/>
+          </a:effectRef>
+          <a:fontRef idx="minor">
+            <a:schemeClr val="lt1"/>
+          </a:fontRef>
+        </p:style>
+        <p:txBody>
+          <a:bodyPr rtlCol="0" anchor="ctr"/>
+          <a:lstStyle/>
+          <a:p>
+            <a:pPr algn="ctr"/>
+          </a:p>
+        </p:txBody>
+      </p:sp>
+      <p:sp>
+        <p:nvSpPr>
+          <p:cNvPr id="3" name="TextBox 2"/>
           <p:cNvSpPr txBox="1"/>
           <p:nvPr/>
         </p:nvSpPr>
         <p:spPr>
           <a:xfrm>
-            <a:off x="914400" y="1828800"/>
-            <a:ext cx="10362895" cy="4114800"/>
+            <a:off x="1097280" y="1280160"/>
+            <a:ext cx="10058400" cy="1097280"/>
           </a:xfrm>
           <a:prstGeom prst="rect">
             <a:avLst/>
@@ -3126,7 +3171,7 @@
           <a:lstStyle/>
           <a:p>
             <a:pPr>
-              <a:defRPr sz="5600" b="1">
+              <a:defRPr sz="6400" b="1">
                 <a:solidFill>
                   <a:srgbClr val="F1F5F9"/>
                 </a:solidFill>
@@ -3137,12 +3182,77 @@
               <a:t>🇱🇦 벨로루트 비엔티안</a:t>
             </a:r>
           </a:p>
+        </p:txBody>
+      </p:sp>
+      <p:sp>
+        <p:nvSpPr>
+          <p:cNvPr id="4" name="Rectangle 3"/>
+          <p:cNvSpPr/>
+          <p:nvPr/>
+        </p:nvSpPr>
+        <p:spPr>
+          <a:xfrm>
+            <a:off x="1097280" y="2468880"/>
+            <a:ext cx="9875520" cy="54864"/>
+          </a:xfrm>
+          <a:prstGeom prst="rect">
+            <a:avLst/>
+          </a:prstGeom>
+          <a:solidFill>
+            <a:srgbClr val="60A5FA"/>
+          </a:solidFill>
+          <a:ln w="12700">
+            <a:solidFill>
+              <a:srgbClr val="60A5FA"/>
+            </a:solidFill>
+          </a:ln>
+        </p:spPr>
+        <p:style>
+          <a:lnRef idx="1">
+            <a:schemeClr val="accent1"/>
+          </a:lnRef>
+          <a:fillRef idx="3">
+            <a:schemeClr val="accent1"/>
+          </a:fillRef>
+          <a:effectRef idx="2">
+            <a:schemeClr val="accent1"/>
+          </a:effectRef>
+          <a:fontRef idx="minor">
+            <a:schemeClr val="lt1"/>
+          </a:fontRef>
+        </p:style>
+        <p:txBody>
+          <a:bodyPr rtlCol="0" anchor="ctr"/>
+          <a:lstStyle/>
+          <a:p>
+            <a:pPr algn="ctr"/>
+          </a:p>
+        </p:txBody>
+      </p:sp>
+      <p:sp>
+        <p:nvSpPr>
+          <p:cNvPr id="5" name="TextBox 4"/>
+          <p:cNvSpPr txBox="1"/>
+          <p:nvPr/>
+        </p:nvSpPr>
+        <p:spPr>
+          <a:xfrm>
+            <a:off x="1097280" y="2651760"/>
+            <a:ext cx="10058400" cy="2926080"/>
+          </a:xfrm>
+          <a:prstGeom prst="rect">
+            <a:avLst/>
+          </a:prstGeom>
+          <a:noFill/>
+        </p:spPr>
+        <p:txBody>
+          <a:bodyPr wrap="square">
+            <a:spAutoFit/>
+          </a:bodyPr>
+          <a:lstStyle/>
           <a:p>
             <a:pPr>
-              <a:spcBef>
-                <a:spcPts val="1000"/>
-              </a:spcBef>
-              <a:defRPr sz="1800" b="1">
+              <a:defRPr sz="2000" b="1">
                 <a:solidFill>
                   <a:srgbClr val="60A5FA"/>
                 </a:solidFill>
@@ -3156,9 +3266,9 @@
           <a:p>
             <a:br/>
             <a:pPr>
-              <a:defRPr sz="1500">
-                <a:solidFill>
-                  <a:srgbClr val="94A3B8"/>
+              <a:defRPr sz="1700">
+                <a:solidFill>
+                  <a:srgbClr val="CBD5E1"/>
                 </a:solidFill>
                 <a:latin typeface="Malgun Gothic"/>
               </a:defRPr>
@@ -3170,7 +3280,7 @@
           <a:p>
             <a:br/>
             <a:pPr>
-              <a:defRPr sz="1300" b="1">
+              <a:defRPr sz="1400" b="1">
                 <a:solidFill>
                   <a:srgbClr val="10B981"/>
                 </a:solidFill>
@@ -3211,13 +3321,58 @@
       <p:grpSpPr/>
       <p:sp>
         <p:nvSpPr>
-          <p:cNvPr id="2" name="TextBox 1"/>
+          <p:cNvPr id="2" name="Rectangle 1"/>
+          <p:cNvSpPr/>
+          <p:nvPr/>
+        </p:nvSpPr>
+        <p:spPr>
+          <a:xfrm>
+            <a:off x="411480" y="365760"/>
+            <a:ext cx="109728" cy="1005840"/>
+          </a:xfrm>
+          <a:prstGeom prst="rect">
+            <a:avLst/>
+          </a:prstGeom>
+          <a:solidFill>
+            <a:srgbClr val="60A5FA"/>
+          </a:solidFill>
+          <a:ln w="12700">
+            <a:solidFill>
+              <a:srgbClr val="60A5FA"/>
+            </a:solidFill>
+          </a:ln>
+        </p:spPr>
+        <p:style>
+          <a:lnRef idx="1">
+            <a:schemeClr val="accent1"/>
+          </a:lnRef>
+          <a:fillRef idx="3">
+            <a:schemeClr val="accent1"/>
+          </a:fillRef>
+          <a:effectRef idx="2">
+            <a:schemeClr val="accent1"/>
+          </a:effectRef>
+          <a:fontRef idx="minor">
+            <a:schemeClr val="lt1"/>
+          </a:fontRef>
+        </p:style>
+        <p:txBody>
+          <a:bodyPr rtlCol="0" anchor="ctr"/>
+          <a:lstStyle/>
+          <a:p>
+            <a:pPr algn="ctr"/>
+          </a:p>
+        </p:txBody>
+      </p:sp>
+      <p:sp>
+        <p:nvSpPr>
+          <p:cNvPr id="3" name="TextBox 2"/>
           <p:cNvSpPr txBox="1"/>
           <p:nvPr/>
         </p:nvSpPr>
         <p:spPr>
           <a:xfrm>
-            <a:off x="731520" y="365760"/>
+            <a:off x="731520" y="320040"/>
             <a:ext cx="10698480" cy="365760"/>
           </a:xfrm>
           <a:prstGeom prst="rect">
@@ -3232,7 +3387,7 @@
           <a:lstStyle/>
           <a:p>
             <a:pPr>
-              <a:defRPr sz="1000" b="1">
+              <a:defRPr sz="1100" b="1">
                 <a:solidFill>
                   <a:srgbClr val="60A5FA"/>
                 </a:solidFill>
@@ -3247,14 +3402,14 @@
       </p:sp>
       <p:sp>
         <p:nvSpPr>
-          <p:cNvPr id="3" name="TextBox 2"/>
+          <p:cNvPr id="4" name="TextBox 3"/>
           <p:cNvSpPr txBox="1"/>
           <p:nvPr/>
         </p:nvSpPr>
         <p:spPr>
           <a:xfrm>
-            <a:off x="731520" y="640080"/>
-            <a:ext cx="10698480" cy="731520"/>
+            <a:off x="731520" y="594360"/>
+            <a:ext cx="10698480" cy="822960"/>
           </a:xfrm>
           <a:prstGeom prst="rect">
             <a:avLst/>
@@ -3268,7 +3423,7 @@
           <a:lstStyle/>
           <a:p>
             <a:pPr>
-              <a:defRPr sz="2800" b="1">
+              <a:defRPr sz="3400" b="1">
                 <a:solidFill>
                   <a:srgbClr val="F1F5F9"/>
                 </a:solidFill>
@@ -3283,14 +3438,59 @@
       </p:sp>
       <p:sp>
         <p:nvSpPr>
-          <p:cNvPr id="4" name="TextBox 3"/>
+          <p:cNvPr id="5" name="Rounded Rectangle 4"/>
+          <p:cNvSpPr/>
+          <p:nvPr/>
+        </p:nvSpPr>
+        <p:spPr>
+          <a:xfrm>
+            <a:off x="731520" y="1554480"/>
+            <a:ext cx="10728655" cy="4754880"/>
+          </a:xfrm>
+          <a:prstGeom prst="roundRect">
+            <a:avLst/>
+          </a:prstGeom>
+          <a:solidFill>
+            <a:srgbClr val="151D2B"/>
+          </a:solidFill>
+          <a:ln w="25400">
+            <a:solidFill>
+              <a:srgbClr val="60A5FA"/>
+            </a:solidFill>
+          </a:ln>
+        </p:spPr>
+        <p:style>
+          <a:lnRef idx="1">
+            <a:schemeClr val="accent1"/>
+          </a:lnRef>
+          <a:fillRef idx="3">
+            <a:schemeClr val="accent1"/>
+          </a:fillRef>
+          <a:effectRef idx="2">
+            <a:schemeClr val="accent1"/>
+          </a:effectRef>
+          <a:fontRef idx="minor">
+            <a:schemeClr val="lt1"/>
+          </a:fontRef>
+        </p:style>
+        <p:txBody>
+          <a:bodyPr rtlCol="0" anchor="ctr"/>
+          <a:lstStyle/>
+          <a:p>
+            <a:pPr algn="ctr"/>
+          </a:p>
+        </p:txBody>
+      </p:sp>
+      <p:sp>
+        <p:nvSpPr>
+          <p:cNvPr id="6" name="TextBox 5"/>
           <p:cNvSpPr txBox="1"/>
           <p:nvPr/>
         </p:nvSpPr>
         <p:spPr>
           <a:xfrm>
-            <a:off x="731520" y="1645920"/>
-            <a:ext cx="10698480" cy="4572000"/>
+            <a:off x="1005840" y="1737360"/>
+            <a:ext cx="10149840" cy="4389120"/>
           </a:xfrm>
           <a:prstGeom prst="rect">
             <a:avLst/>
@@ -3305,9 +3505,9 @@
           <a:p>
             <a:pPr>
               <a:spcBef>
-                <a:spcPts val="1200"/>
+                <a:spcPts val="1400"/>
               </a:spcBef>
-              <a:defRPr sz="1800" b="1">
+              <a:defRPr sz="2100" b="1">
                 <a:solidFill>
                   <a:srgbClr val="60A5FA"/>
                 </a:solidFill>
@@ -3321,9 +3521,9 @@
           <a:p>
             <a:pPr lvl="1">
               <a:spcBef>
-                <a:spcPts val="300"/>
+                <a:spcPts val="400"/>
               </a:spcBef>
-              <a:defRPr sz="1400">
+              <a:defRPr sz="1600">
                 <a:solidFill>
                   <a:srgbClr val="F1F5F9"/>
                 </a:solidFill>
@@ -3341,9 +3541,9 @@
           <a:p>
             <a:pPr>
               <a:spcBef>
-                <a:spcPts val="1200"/>
+                <a:spcPts val="1400"/>
               </a:spcBef>
-              <a:defRPr sz="1800" b="1">
+              <a:defRPr sz="2100" b="1">
                 <a:solidFill>
                   <a:srgbClr val="60A5FA"/>
                 </a:solidFill>
@@ -3357,9 +3557,9 @@
           <a:p>
             <a:pPr lvl="1">
               <a:spcBef>
-                <a:spcPts val="300"/>
+                <a:spcPts val="400"/>
               </a:spcBef>
-              <a:defRPr sz="1400">
+              <a:defRPr sz="1600">
                 <a:solidFill>
                   <a:srgbClr val="F1F5F9"/>
                 </a:solidFill>
@@ -3377,9 +3577,9 @@
           <a:p>
             <a:pPr>
               <a:spcBef>
-                <a:spcPts val="1200"/>
+                <a:spcPts val="1400"/>
               </a:spcBef>
-              <a:defRPr sz="1800" b="1">
+              <a:defRPr sz="2100" b="1">
                 <a:solidFill>
                   <a:srgbClr val="60A5FA"/>
                 </a:solidFill>
@@ -3393,9 +3593,9 @@
           <a:p>
             <a:pPr lvl="1">
               <a:spcBef>
-                <a:spcPts val="300"/>
+                <a:spcPts val="400"/>
               </a:spcBef>
-              <a:defRPr sz="1400">
+              <a:defRPr sz="1600">
                 <a:solidFill>
                   <a:srgbClr val="F1F5F9"/>
                 </a:solidFill>
@@ -3440,13 +3640,58 @@
       <p:grpSpPr/>
       <p:sp>
         <p:nvSpPr>
-          <p:cNvPr id="2" name="TextBox 1"/>
+          <p:cNvPr id="2" name="Rectangle 1"/>
+          <p:cNvSpPr/>
+          <p:nvPr/>
+        </p:nvSpPr>
+        <p:spPr>
+          <a:xfrm>
+            <a:off x="411480" y="365760"/>
+            <a:ext cx="109728" cy="1005840"/>
+          </a:xfrm>
+          <a:prstGeom prst="rect">
+            <a:avLst/>
+          </a:prstGeom>
+          <a:solidFill>
+            <a:srgbClr val="60A5FA"/>
+          </a:solidFill>
+          <a:ln w="12700">
+            <a:solidFill>
+              <a:srgbClr val="60A5FA"/>
+            </a:solidFill>
+          </a:ln>
+        </p:spPr>
+        <p:style>
+          <a:lnRef idx="1">
+            <a:schemeClr val="accent1"/>
+          </a:lnRef>
+          <a:fillRef idx="3">
+            <a:schemeClr val="accent1"/>
+          </a:fillRef>
+          <a:effectRef idx="2">
+            <a:schemeClr val="accent1"/>
+          </a:effectRef>
+          <a:fontRef idx="minor">
+            <a:schemeClr val="lt1"/>
+          </a:fontRef>
+        </p:style>
+        <p:txBody>
+          <a:bodyPr rtlCol="0" anchor="ctr"/>
+          <a:lstStyle/>
+          <a:p>
+            <a:pPr algn="ctr"/>
+          </a:p>
+        </p:txBody>
+      </p:sp>
+      <p:sp>
+        <p:nvSpPr>
+          <p:cNvPr id="3" name="TextBox 2"/>
           <p:cNvSpPr txBox="1"/>
           <p:nvPr/>
         </p:nvSpPr>
         <p:spPr>
           <a:xfrm>
-            <a:off x="731520" y="365760"/>
+            <a:off x="731520" y="320040"/>
             <a:ext cx="10698480" cy="365760"/>
           </a:xfrm>
           <a:prstGeom prst="rect">
@@ -3461,7 +3706,7 @@
           <a:lstStyle/>
           <a:p>
             <a:pPr>
-              <a:defRPr sz="1000" b="1">
+              <a:defRPr sz="1100" b="1">
                 <a:solidFill>
                   <a:srgbClr val="60A5FA"/>
                 </a:solidFill>
@@ -3476,14 +3721,14 @@
       </p:sp>
       <p:sp>
         <p:nvSpPr>
-          <p:cNvPr id="3" name="TextBox 2"/>
+          <p:cNvPr id="4" name="TextBox 3"/>
           <p:cNvSpPr txBox="1"/>
           <p:nvPr/>
         </p:nvSpPr>
         <p:spPr>
           <a:xfrm>
-            <a:off x="731520" y="640080"/>
-            <a:ext cx="10698480" cy="731520"/>
+            <a:off x="731520" y="594360"/>
+            <a:ext cx="10698480" cy="822960"/>
           </a:xfrm>
           <a:prstGeom prst="rect">
             <a:avLst/>
@@ -3497,7 +3742,7 @@
           <a:lstStyle/>
           <a:p>
             <a:pPr>
-              <a:defRPr sz="2800" b="1">
+              <a:defRPr sz="3400" b="1">
                 <a:solidFill>
                   <a:srgbClr val="F1F5F9"/>
                 </a:solidFill>
@@ -3512,14 +3757,104 @@
       </p:sp>
       <p:sp>
         <p:nvSpPr>
-          <p:cNvPr id="4" name="TextBox 3"/>
+          <p:cNvPr id="5" name="Rounded Rectangle 4"/>
+          <p:cNvSpPr/>
+          <p:nvPr/>
+        </p:nvSpPr>
+        <p:spPr>
+          <a:xfrm>
+            <a:off x="731520" y="1554480"/>
+            <a:ext cx="5120640" cy="4754880"/>
+          </a:xfrm>
+          <a:prstGeom prst="roundRect">
+            <a:avLst/>
+          </a:prstGeom>
+          <a:solidFill>
+            <a:srgbClr val="151D2B"/>
+          </a:solidFill>
+          <a:ln w="25400">
+            <a:solidFill>
+              <a:srgbClr val="60A5FA"/>
+            </a:solidFill>
+          </a:ln>
+        </p:spPr>
+        <p:style>
+          <a:lnRef idx="1">
+            <a:schemeClr val="accent1"/>
+          </a:lnRef>
+          <a:fillRef idx="3">
+            <a:schemeClr val="accent1"/>
+          </a:fillRef>
+          <a:effectRef idx="2">
+            <a:schemeClr val="accent1"/>
+          </a:effectRef>
+          <a:fontRef idx="minor">
+            <a:schemeClr val="lt1"/>
+          </a:fontRef>
+        </p:style>
+        <p:txBody>
+          <a:bodyPr rtlCol="0" anchor="ctr"/>
+          <a:lstStyle/>
+          <a:p>
+            <a:pPr algn="ctr"/>
+          </a:p>
+        </p:txBody>
+      </p:sp>
+      <p:sp>
+        <p:nvSpPr>
+          <p:cNvPr id="6" name="Rounded Rectangle 5"/>
+          <p:cNvSpPr/>
+          <p:nvPr/>
+        </p:nvSpPr>
+        <p:spPr>
+          <a:xfrm>
+            <a:off x="6217920" y="1554480"/>
+            <a:ext cx="5212080" cy="4754880"/>
+          </a:xfrm>
+          <a:prstGeom prst="roundRect">
+            <a:avLst/>
+          </a:prstGeom>
+          <a:solidFill>
+            <a:srgbClr val="151D2B"/>
+          </a:solidFill>
+          <a:ln w="25400">
+            <a:solidFill>
+              <a:srgbClr val="60A5FA"/>
+            </a:solidFill>
+          </a:ln>
+        </p:spPr>
+        <p:style>
+          <a:lnRef idx="1">
+            <a:schemeClr val="accent1"/>
+          </a:lnRef>
+          <a:fillRef idx="3">
+            <a:schemeClr val="accent1"/>
+          </a:fillRef>
+          <a:effectRef idx="2">
+            <a:schemeClr val="accent1"/>
+          </a:effectRef>
+          <a:fontRef idx="minor">
+            <a:schemeClr val="lt1"/>
+          </a:fontRef>
+        </p:style>
+        <p:txBody>
+          <a:bodyPr rtlCol="0" anchor="ctr"/>
+          <a:lstStyle/>
+          <a:p>
+            <a:pPr algn="ctr"/>
+          </a:p>
+        </p:txBody>
+      </p:sp>
+      <p:sp>
+        <p:nvSpPr>
+          <p:cNvPr id="7" name="TextBox 6"/>
           <p:cNvSpPr txBox="1"/>
           <p:nvPr/>
         </p:nvSpPr>
         <p:spPr>
           <a:xfrm>
-            <a:off x="731520" y="1645920"/>
-            <a:ext cx="5120640" cy="4572000"/>
+            <a:off x="914400" y="1737360"/>
+            <a:ext cx="4754880" cy="4389120"/>
           </a:xfrm>
           <a:prstGeom prst="rect">
             <a:avLst/>
@@ -3534,9 +3869,9 @@
           <a:p>
             <a:pPr>
               <a:spcBef>
-                <a:spcPts val="1200"/>
+                <a:spcPts val="1400"/>
               </a:spcBef>
-              <a:defRPr sz="1800" b="1">
+              <a:defRPr sz="2100" b="1">
                 <a:solidFill>
                   <a:srgbClr val="60A5FA"/>
                 </a:solidFill>
@@ -3550,9 +3885,9 @@
           <a:p>
             <a:pPr lvl="1">
               <a:spcBef>
-                <a:spcPts val="300"/>
+                <a:spcPts val="400"/>
               </a:spcBef>
-              <a:defRPr sz="1400">
+              <a:defRPr sz="1600">
                 <a:solidFill>
                   <a:srgbClr val="F1F5F9"/>
                 </a:solidFill>
@@ -3574,9 +3909,9 @@
           <a:p>
             <a:pPr>
               <a:spcBef>
-                <a:spcPts val="1200"/>
+                <a:spcPts val="1400"/>
               </a:spcBef>
-              <a:defRPr sz="1800" b="1">
+              <a:defRPr sz="2100" b="1">
                 <a:solidFill>
                   <a:srgbClr val="60A5FA"/>
                 </a:solidFill>
@@ -3590,9 +3925,9 @@
           <a:p>
             <a:pPr lvl="1">
               <a:spcBef>
-                <a:spcPts val="300"/>
+                <a:spcPts val="400"/>
               </a:spcBef>
-              <a:defRPr sz="1400">
+              <a:defRPr sz="1600">
                 <a:solidFill>
                   <a:srgbClr val="F1F5F9"/>
                 </a:solidFill>
@@ -3615,14 +3950,14 @@
       </p:sp>
       <p:sp>
         <p:nvSpPr>
-          <p:cNvPr id="5" name="TextBox 4"/>
+          <p:cNvPr id="8" name="TextBox 7"/>
           <p:cNvSpPr txBox="1"/>
           <p:nvPr/>
         </p:nvSpPr>
         <p:spPr>
           <a:xfrm>
-            <a:off x="6217920" y="1645920"/>
-            <a:ext cx="5212080" cy="4572000"/>
+            <a:off x="6400800" y="1737360"/>
+            <a:ext cx="4846320" cy="4389120"/>
           </a:xfrm>
           <a:prstGeom prst="rect">
             <a:avLst/>
@@ -3637,9 +3972,9 @@
           <a:p>
             <a:pPr>
               <a:spcBef>
-                <a:spcPts val="1200"/>
+                <a:spcPts val="1400"/>
               </a:spcBef>
-              <a:defRPr sz="1800" b="1">
+              <a:defRPr sz="2100" b="1">
                 <a:solidFill>
                   <a:srgbClr val="60A5FA"/>
                 </a:solidFill>
@@ -3653,9 +3988,9 @@
           <a:p>
             <a:pPr lvl="1">
               <a:spcBef>
-                <a:spcPts val="300"/>
+                <a:spcPts val="400"/>
               </a:spcBef>
-              <a:defRPr sz="1400">
+              <a:defRPr sz="1600">
                 <a:solidFill>
                   <a:srgbClr val="F1F5F9"/>
                 </a:solidFill>
@@ -3677,9 +4012,9 @@
           <a:p>
             <a:pPr>
               <a:spcBef>
-                <a:spcPts val="1200"/>
+                <a:spcPts val="1400"/>
               </a:spcBef>
-              <a:defRPr sz="1800" b="1">
+              <a:defRPr sz="2100" b="1">
                 <a:solidFill>
                   <a:srgbClr val="60A5FA"/>
                 </a:solidFill>
@@ -3693,9 +4028,9 @@
           <a:p>
             <a:pPr lvl="1">
               <a:spcBef>
-                <a:spcPts val="300"/>
+                <a:spcPts val="400"/>
               </a:spcBef>
-              <a:defRPr sz="1400">
+              <a:defRPr sz="1600">
                 <a:solidFill>
                   <a:srgbClr val="F1F5F9"/>
                 </a:solidFill>
@@ -3736,13 +4071,58 @@
       <p:grpSpPr/>
       <p:sp>
         <p:nvSpPr>
-          <p:cNvPr id="2" name="TextBox 1"/>
+          <p:cNvPr id="2" name="Rectangle 1"/>
+          <p:cNvSpPr/>
+          <p:nvPr/>
+        </p:nvSpPr>
+        <p:spPr>
+          <a:xfrm>
+            <a:off x="411480" y="365760"/>
+            <a:ext cx="109728" cy="1005840"/>
+          </a:xfrm>
+          <a:prstGeom prst="rect">
+            <a:avLst/>
+          </a:prstGeom>
+          <a:solidFill>
+            <a:srgbClr val="60A5FA"/>
+          </a:solidFill>
+          <a:ln w="12700">
+            <a:solidFill>
+              <a:srgbClr val="60A5FA"/>
+            </a:solidFill>
+          </a:ln>
+        </p:spPr>
+        <p:style>
+          <a:lnRef idx="1">
+            <a:schemeClr val="accent1"/>
+          </a:lnRef>
+          <a:fillRef idx="3">
+            <a:schemeClr val="accent1"/>
+          </a:fillRef>
+          <a:effectRef idx="2">
+            <a:schemeClr val="accent1"/>
+          </a:effectRef>
+          <a:fontRef idx="minor">
+            <a:schemeClr val="lt1"/>
+          </a:fontRef>
+        </p:style>
+        <p:txBody>
+          <a:bodyPr rtlCol="0" anchor="ctr"/>
+          <a:lstStyle/>
+          <a:p>
+            <a:pPr algn="ctr"/>
+          </a:p>
+        </p:txBody>
+      </p:sp>
+      <p:sp>
+        <p:nvSpPr>
+          <p:cNvPr id="3" name="TextBox 2"/>
           <p:cNvSpPr txBox="1"/>
           <p:nvPr/>
         </p:nvSpPr>
         <p:spPr>
           <a:xfrm>
-            <a:off x="731520" y="365760"/>
+            <a:off x="731520" y="320040"/>
             <a:ext cx="10698480" cy="365760"/>
           </a:xfrm>
           <a:prstGeom prst="rect">
@@ -3757,7 +4137,7 @@
           <a:lstStyle/>
           <a:p>
             <a:pPr>
-              <a:defRPr sz="1000" b="1">
+              <a:defRPr sz="1100" b="1">
                 <a:solidFill>
                   <a:srgbClr val="60A5FA"/>
                 </a:solidFill>
@@ -3772,14 +4152,14 @@
       </p:sp>
       <p:sp>
         <p:nvSpPr>
-          <p:cNvPr id="3" name="TextBox 2"/>
+          <p:cNvPr id="4" name="TextBox 3"/>
           <p:cNvSpPr txBox="1"/>
           <p:nvPr/>
         </p:nvSpPr>
         <p:spPr>
           <a:xfrm>
-            <a:off x="731520" y="640080"/>
-            <a:ext cx="10698480" cy="731520"/>
+            <a:off x="731520" y="594360"/>
+            <a:ext cx="10698480" cy="822960"/>
           </a:xfrm>
           <a:prstGeom prst="rect">
             <a:avLst/>
@@ -3793,7 +4173,7 @@
           <a:lstStyle/>
           <a:p>
             <a:pPr>
-              <a:defRPr sz="2800" b="1">
+              <a:defRPr sz="3400" b="1">
                 <a:solidFill>
                   <a:srgbClr val="F1F5F9"/>
                 </a:solidFill>
@@ -3808,14 +4188,59 @@
       </p:sp>
       <p:sp>
         <p:nvSpPr>
-          <p:cNvPr id="4" name="TextBox 3"/>
+          <p:cNvPr id="5" name="Rounded Rectangle 4"/>
+          <p:cNvSpPr/>
+          <p:nvPr/>
+        </p:nvSpPr>
+        <p:spPr>
+          <a:xfrm>
+            <a:off x="731520" y="1554480"/>
+            <a:ext cx="10728655" cy="4754880"/>
+          </a:xfrm>
+          <a:prstGeom prst="roundRect">
+            <a:avLst/>
+          </a:prstGeom>
+          <a:solidFill>
+            <a:srgbClr val="151D2B"/>
+          </a:solidFill>
+          <a:ln w="25400">
+            <a:solidFill>
+              <a:srgbClr val="10B981"/>
+            </a:solidFill>
+          </a:ln>
+        </p:spPr>
+        <p:style>
+          <a:lnRef idx="1">
+            <a:schemeClr val="accent1"/>
+          </a:lnRef>
+          <a:fillRef idx="3">
+            <a:schemeClr val="accent1"/>
+          </a:fillRef>
+          <a:effectRef idx="2">
+            <a:schemeClr val="accent1"/>
+          </a:effectRef>
+          <a:fontRef idx="minor">
+            <a:schemeClr val="lt1"/>
+          </a:fontRef>
+        </p:style>
+        <p:txBody>
+          <a:bodyPr rtlCol="0" anchor="ctr"/>
+          <a:lstStyle/>
+          <a:p>
+            <a:pPr algn="ctr"/>
+          </a:p>
+        </p:txBody>
+      </p:sp>
+      <p:sp>
+        <p:nvSpPr>
+          <p:cNvPr id="6" name="TextBox 5"/>
           <p:cNvSpPr txBox="1"/>
           <p:nvPr/>
         </p:nvSpPr>
         <p:spPr>
           <a:xfrm>
-            <a:off x="731520" y="1645920"/>
-            <a:ext cx="10698480" cy="4572000"/>
+            <a:off x="1005840" y="1737360"/>
+            <a:ext cx="10149840" cy="4389120"/>
           </a:xfrm>
           <a:prstGeom prst="rect">
             <a:avLst/>
@@ -3830,9 +4255,9 @@
           <a:p>
             <a:pPr>
               <a:spcBef>
-                <a:spcPts val="1200"/>
+                <a:spcPts val="1400"/>
               </a:spcBef>
-              <a:defRPr sz="1800" b="1">
+              <a:defRPr sz="2100" b="1">
                 <a:solidFill>
                   <a:srgbClr val="60A5FA"/>
                 </a:solidFill>
@@ -3846,9 +4271,9 @@
           <a:p>
             <a:pPr lvl="1">
               <a:spcBef>
-                <a:spcPts val="300"/>
+                <a:spcPts val="400"/>
               </a:spcBef>
-              <a:defRPr sz="1400">
+              <a:defRPr sz="1600">
                 <a:solidFill>
                   <a:srgbClr val="F1F5F9"/>
                 </a:solidFill>
@@ -3874,9 +4299,9 @@
           <a:p>
             <a:pPr>
               <a:spcBef>
-                <a:spcPts val="1200"/>
+                <a:spcPts val="1400"/>
               </a:spcBef>
-              <a:defRPr sz="1800" b="1">
+              <a:defRPr sz="2100" b="1">
                 <a:solidFill>
                   <a:srgbClr val="60A5FA"/>
                 </a:solidFill>
@@ -3890,9 +4315,9 @@
           <a:p>
             <a:pPr lvl="1">
               <a:spcBef>
-                <a:spcPts val="300"/>
+                <a:spcPts val="400"/>
               </a:spcBef>
-              <a:defRPr sz="1400">
+              <a:defRPr sz="1600">
                 <a:solidFill>
                   <a:srgbClr val="F1F5F9"/>
                 </a:solidFill>
@@ -3914,9 +4339,9 @@
           <a:p>
             <a:pPr>
               <a:spcBef>
-                <a:spcPts val="1200"/>
+                <a:spcPts val="1400"/>
               </a:spcBef>
-              <a:defRPr sz="1800" b="1">
+              <a:defRPr sz="2100" b="1">
                 <a:solidFill>
                   <a:srgbClr val="60A5FA"/>
                 </a:solidFill>
@@ -3930,9 +4355,9 @@
           <a:p>
             <a:pPr lvl="1">
               <a:spcBef>
-                <a:spcPts val="300"/>
+                <a:spcPts val="400"/>
               </a:spcBef>
-              <a:defRPr sz="1400">
+              <a:defRPr sz="1600">
                 <a:solidFill>
                   <a:srgbClr val="F1F5F9"/>
                 </a:solidFill>
@@ -3954,9 +4379,9 @@
           <a:p>
             <a:pPr>
               <a:spcBef>
-                <a:spcPts val="1200"/>
+                <a:spcPts val="1400"/>
               </a:spcBef>
-              <a:defRPr sz="1800" b="1">
+              <a:defRPr sz="2100" b="1">
                 <a:solidFill>
                   <a:srgbClr val="60A5FA"/>
                 </a:solidFill>
@@ -3970,9 +4395,9 @@
           <a:p>
             <a:pPr lvl="1">
               <a:spcBef>
-                <a:spcPts val="300"/>
+                <a:spcPts val="400"/>
               </a:spcBef>
-              <a:defRPr sz="1400">
+              <a:defRPr sz="1600">
                 <a:solidFill>
                   <a:srgbClr val="F1F5F9"/>
                 </a:solidFill>
@@ -4021,13 +4446,58 @@
       <p:grpSpPr/>
       <p:sp>
         <p:nvSpPr>
-          <p:cNvPr id="2" name="TextBox 1"/>
+          <p:cNvPr id="2" name="Rectangle 1"/>
+          <p:cNvSpPr/>
+          <p:nvPr/>
+        </p:nvSpPr>
+        <p:spPr>
+          <a:xfrm>
+            <a:off x="411480" y="365760"/>
+            <a:ext cx="109728" cy="1005840"/>
+          </a:xfrm>
+          <a:prstGeom prst="rect">
+            <a:avLst/>
+          </a:prstGeom>
+          <a:solidFill>
+            <a:srgbClr val="60A5FA"/>
+          </a:solidFill>
+          <a:ln w="12700">
+            <a:solidFill>
+              <a:srgbClr val="60A5FA"/>
+            </a:solidFill>
+          </a:ln>
+        </p:spPr>
+        <p:style>
+          <a:lnRef idx="1">
+            <a:schemeClr val="accent1"/>
+          </a:lnRef>
+          <a:fillRef idx="3">
+            <a:schemeClr val="accent1"/>
+          </a:fillRef>
+          <a:effectRef idx="2">
+            <a:schemeClr val="accent1"/>
+          </a:effectRef>
+          <a:fontRef idx="minor">
+            <a:schemeClr val="lt1"/>
+          </a:fontRef>
+        </p:style>
+        <p:txBody>
+          <a:bodyPr rtlCol="0" anchor="ctr"/>
+          <a:lstStyle/>
+          <a:p>
+            <a:pPr algn="ctr"/>
+          </a:p>
+        </p:txBody>
+      </p:sp>
+      <p:sp>
+        <p:nvSpPr>
+          <p:cNvPr id="3" name="TextBox 2"/>
           <p:cNvSpPr txBox="1"/>
           <p:nvPr/>
         </p:nvSpPr>
         <p:spPr>
           <a:xfrm>
-            <a:off x="731520" y="365760"/>
+            <a:off x="731520" y="320040"/>
             <a:ext cx="10698480" cy="365760"/>
           </a:xfrm>
           <a:prstGeom prst="rect">
@@ -4042,7 +4512,7 @@
           <a:lstStyle/>
           <a:p>
             <a:pPr>
-              <a:defRPr sz="1000" b="1">
+              <a:defRPr sz="1100" b="1">
                 <a:solidFill>
                   <a:srgbClr val="60A5FA"/>
                 </a:solidFill>
@@ -4057,14 +4527,14 @@
       </p:sp>
       <p:sp>
         <p:nvSpPr>
-          <p:cNvPr id="3" name="TextBox 2"/>
+          <p:cNvPr id="4" name="TextBox 3"/>
           <p:cNvSpPr txBox="1"/>
           <p:nvPr/>
         </p:nvSpPr>
         <p:spPr>
           <a:xfrm>
-            <a:off x="731520" y="640080"/>
-            <a:ext cx="10698480" cy="731520"/>
+            <a:off x="731520" y="594360"/>
+            <a:ext cx="10698480" cy="822960"/>
           </a:xfrm>
           <a:prstGeom prst="rect">
             <a:avLst/>
@@ -4078,7 +4548,7 @@
           <a:lstStyle/>
           <a:p>
             <a:pPr>
-              <a:defRPr sz="2800" b="1">
+              <a:defRPr sz="3400" b="1">
                 <a:solidFill>
                   <a:srgbClr val="F1F5F9"/>
                 </a:solidFill>
@@ -4093,14 +4563,104 @@
       </p:sp>
       <p:sp>
         <p:nvSpPr>
-          <p:cNvPr id="4" name="TextBox 3"/>
+          <p:cNvPr id="5" name="Rounded Rectangle 4"/>
+          <p:cNvSpPr/>
+          <p:nvPr/>
+        </p:nvSpPr>
+        <p:spPr>
+          <a:xfrm>
+            <a:off x="731520" y="1554480"/>
+            <a:ext cx="5120640" cy="4754880"/>
+          </a:xfrm>
+          <a:prstGeom prst="roundRect">
+            <a:avLst/>
+          </a:prstGeom>
+          <a:solidFill>
+            <a:srgbClr val="151D2B"/>
+          </a:solidFill>
+          <a:ln w="25400">
+            <a:solidFill>
+              <a:srgbClr val="60A5FA"/>
+            </a:solidFill>
+          </a:ln>
+        </p:spPr>
+        <p:style>
+          <a:lnRef idx="1">
+            <a:schemeClr val="accent1"/>
+          </a:lnRef>
+          <a:fillRef idx="3">
+            <a:schemeClr val="accent1"/>
+          </a:fillRef>
+          <a:effectRef idx="2">
+            <a:schemeClr val="accent1"/>
+          </a:effectRef>
+          <a:fontRef idx="minor">
+            <a:schemeClr val="lt1"/>
+          </a:fontRef>
+        </p:style>
+        <p:txBody>
+          <a:bodyPr rtlCol="0" anchor="ctr"/>
+          <a:lstStyle/>
+          <a:p>
+            <a:pPr algn="ctr"/>
+          </a:p>
+        </p:txBody>
+      </p:sp>
+      <p:sp>
+        <p:nvSpPr>
+          <p:cNvPr id="6" name="Rounded Rectangle 5"/>
+          <p:cNvSpPr/>
+          <p:nvPr/>
+        </p:nvSpPr>
+        <p:spPr>
+          <a:xfrm>
+            <a:off x="6217920" y="1554480"/>
+            <a:ext cx="5212080" cy="4754880"/>
+          </a:xfrm>
+          <a:prstGeom prst="roundRect">
+            <a:avLst/>
+          </a:prstGeom>
+          <a:solidFill>
+            <a:srgbClr val="151D2B"/>
+          </a:solidFill>
+          <a:ln w="25400">
+            <a:solidFill>
+              <a:srgbClr val="10B981"/>
+            </a:solidFill>
+          </a:ln>
+        </p:spPr>
+        <p:style>
+          <a:lnRef idx="1">
+            <a:schemeClr val="accent1"/>
+          </a:lnRef>
+          <a:fillRef idx="3">
+            <a:schemeClr val="accent1"/>
+          </a:fillRef>
+          <a:effectRef idx="2">
+            <a:schemeClr val="accent1"/>
+          </a:effectRef>
+          <a:fontRef idx="minor">
+            <a:schemeClr val="lt1"/>
+          </a:fontRef>
+        </p:style>
+        <p:txBody>
+          <a:bodyPr rtlCol="0" anchor="ctr"/>
+          <a:lstStyle/>
+          <a:p>
+            <a:pPr algn="ctr"/>
+          </a:p>
+        </p:txBody>
+      </p:sp>
+      <p:sp>
+        <p:nvSpPr>
+          <p:cNvPr id="7" name="TextBox 6"/>
           <p:cNvSpPr txBox="1"/>
           <p:nvPr/>
         </p:nvSpPr>
         <p:spPr>
           <a:xfrm>
-            <a:off x="731520" y="1645920"/>
-            <a:ext cx="5120640" cy="4572000"/>
+            <a:off x="914400" y="1737360"/>
+            <a:ext cx="4754880" cy="4389120"/>
           </a:xfrm>
           <a:prstGeom prst="rect">
             <a:avLst/>
@@ -4115,9 +4675,9 @@
           <a:p>
             <a:pPr>
               <a:spcBef>
-                <a:spcPts val="1200"/>
+                <a:spcPts val="1400"/>
               </a:spcBef>
-              <a:defRPr sz="1800" b="1">
+              <a:defRPr sz="2100" b="1">
                 <a:solidFill>
                   <a:srgbClr val="60A5FA"/>
                 </a:solidFill>
@@ -4131,9 +4691,9 @@
           <a:p>
             <a:pPr lvl="1">
               <a:spcBef>
-                <a:spcPts val="300"/>
+                <a:spcPts val="400"/>
               </a:spcBef>
-              <a:defRPr sz="1400">
+              <a:defRPr sz="1600">
                 <a:solidFill>
                   <a:srgbClr val="F1F5F9"/>
                 </a:solidFill>
@@ -4155,9 +4715,9 @@
           <a:p>
             <a:pPr>
               <a:spcBef>
-                <a:spcPts val="1200"/>
+                <a:spcPts val="1400"/>
               </a:spcBef>
-              <a:defRPr sz="1800" b="1">
+              <a:defRPr sz="2100" b="1">
                 <a:solidFill>
                   <a:srgbClr val="60A5FA"/>
                 </a:solidFill>
@@ -4171,9 +4731,9 @@
           <a:p>
             <a:pPr lvl="1">
               <a:spcBef>
-                <a:spcPts val="300"/>
+                <a:spcPts val="400"/>
               </a:spcBef>
-              <a:defRPr sz="1400">
+              <a:defRPr sz="1600">
                 <a:solidFill>
                   <a:srgbClr val="F1F5F9"/>
                 </a:solidFill>
@@ -4192,14 +4752,14 @@
       </p:sp>
       <p:sp>
         <p:nvSpPr>
-          <p:cNvPr id="5" name="TextBox 4"/>
+          <p:cNvPr id="8" name="TextBox 7"/>
           <p:cNvSpPr txBox="1"/>
           <p:nvPr/>
         </p:nvSpPr>
         <p:spPr>
           <a:xfrm>
-            <a:off x="6217920" y="1645920"/>
-            <a:ext cx="5212080" cy="4572000"/>
+            <a:off x="6400800" y="1737360"/>
+            <a:ext cx="4846320" cy="4389120"/>
           </a:xfrm>
           <a:prstGeom prst="rect">
             <a:avLst/>
@@ -4214,9 +4774,9 @@
           <a:p>
             <a:pPr>
               <a:spcBef>
-                <a:spcPts val="1200"/>
+                <a:spcPts val="1400"/>
               </a:spcBef>
-              <a:defRPr sz="1800" b="1">
+              <a:defRPr sz="2100" b="1">
                 <a:solidFill>
                   <a:srgbClr val="60A5FA"/>
                 </a:solidFill>
@@ -4230,9 +4790,9 @@
           <a:p>
             <a:pPr lvl="1">
               <a:spcBef>
-                <a:spcPts val="300"/>
+                <a:spcPts val="400"/>
               </a:spcBef>
-              <a:defRPr sz="1400">
+              <a:defRPr sz="1600">
                 <a:solidFill>
                   <a:srgbClr val="F1F5F9"/>
                 </a:solidFill>
@@ -4250,9 +4810,9 @@
           <a:p>
             <a:pPr>
               <a:spcBef>
-                <a:spcPts val="1200"/>
+                <a:spcPts val="1400"/>
               </a:spcBef>
-              <a:defRPr sz="1800" b="1">
+              <a:defRPr sz="2100" b="1">
                 <a:solidFill>
                   <a:srgbClr val="60A5FA"/>
                 </a:solidFill>
@@ -4266,9 +4826,9 @@
           <a:p>
             <a:pPr lvl="1">
               <a:spcBef>
-                <a:spcPts val="300"/>
+                <a:spcPts val="400"/>
               </a:spcBef>
-              <a:defRPr sz="1400">
+              <a:defRPr sz="1600">
                 <a:solidFill>
                   <a:srgbClr val="F1F5F9"/>
                 </a:solidFill>
@@ -4309,13 +4869,58 @@
       <p:grpSpPr/>
       <p:sp>
         <p:nvSpPr>
-          <p:cNvPr id="2" name="TextBox 1"/>
+          <p:cNvPr id="2" name="Rectangle 1"/>
+          <p:cNvSpPr/>
+          <p:nvPr/>
+        </p:nvSpPr>
+        <p:spPr>
+          <a:xfrm>
+            <a:off x="411480" y="365760"/>
+            <a:ext cx="109728" cy="1005840"/>
+          </a:xfrm>
+          <a:prstGeom prst="rect">
+            <a:avLst/>
+          </a:prstGeom>
+          <a:solidFill>
+            <a:srgbClr val="60A5FA"/>
+          </a:solidFill>
+          <a:ln w="12700">
+            <a:solidFill>
+              <a:srgbClr val="60A5FA"/>
+            </a:solidFill>
+          </a:ln>
+        </p:spPr>
+        <p:style>
+          <a:lnRef idx="1">
+            <a:schemeClr val="accent1"/>
+          </a:lnRef>
+          <a:fillRef idx="3">
+            <a:schemeClr val="accent1"/>
+          </a:fillRef>
+          <a:effectRef idx="2">
+            <a:schemeClr val="accent1"/>
+          </a:effectRef>
+          <a:fontRef idx="minor">
+            <a:schemeClr val="lt1"/>
+          </a:fontRef>
+        </p:style>
+        <p:txBody>
+          <a:bodyPr rtlCol="0" anchor="ctr"/>
+          <a:lstStyle/>
+          <a:p>
+            <a:pPr algn="ctr"/>
+          </a:p>
+        </p:txBody>
+      </p:sp>
+      <p:sp>
+        <p:nvSpPr>
+          <p:cNvPr id="3" name="TextBox 2"/>
           <p:cNvSpPr txBox="1"/>
           <p:nvPr/>
         </p:nvSpPr>
         <p:spPr>
           <a:xfrm>
-            <a:off x="731520" y="365760"/>
+            <a:off x="731520" y="320040"/>
             <a:ext cx="10698480" cy="365760"/>
           </a:xfrm>
           <a:prstGeom prst="rect">
@@ -4330,7 +4935,7 @@
           <a:lstStyle/>
           <a:p>
             <a:pPr>
-              <a:defRPr sz="1000" b="1">
+              <a:defRPr sz="1100" b="1">
                 <a:solidFill>
                   <a:srgbClr val="60A5FA"/>
                 </a:solidFill>
@@ -4345,14 +4950,14 @@
       </p:sp>
       <p:sp>
         <p:nvSpPr>
-          <p:cNvPr id="3" name="TextBox 2"/>
+          <p:cNvPr id="4" name="TextBox 3"/>
           <p:cNvSpPr txBox="1"/>
           <p:nvPr/>
         </p:nvSpPr>
         <p:spPr>
           <a:xfrm>
-            <a:off x="731520" y="640080"/>
-            <a:ext cx="10698480" cy="731520"/>
+            <a:off x="731520" y="594360"/>
+            <a:ext cx="10698480" cy="822960"/>
           </a:xfrm>
           <a:prstGeom prst="rect">
             <a:avLst/>
@@ -4366,7 +4971,7 @@
           <a:lstStyle/>
           <a:p>
             <a:pPr>
-              <a:defRPr sz="2800" b="1">
+              <a:defRPr sz="3400" b="1">
                 <a:solidFill>
                   <a:srgbClr val="F1F5F9"/>
                 </a:solidFill>
@@ -4381,14 +4986,59 @@
       </p:sp>
       <p:sp>
         <p:nvSpPr>
-          <p:cNvPr id="4" name="TextBox 3"/>
+          <p:cNvPr id="5" name="Rounded Rectangle 4"/>
+          <p:cNvSpPr/>
+          <p:nvPr/>
+        </p:nvSpPr>
+        <p:spPr>
+          <a:xfrm>
+            <a:off x="731520" y="1554480"/>
+            <a:ext cx="10728655" cy="4754880"/>
+          </a:xfrm>
+          <a:prstGeom prst="roundRect">
+            <a:avLst/>
+          </a:prstGeom>
+          <a:solidFill>
+            <a:srgbClr val="151D2B"/>
+          </a:solidFill>
+          <a:ln w="25400">
+            <a:solidFill>
+              <a:srgbClr val="60A5FA"/>
+            </a:solidFill>
+          </a:ln>
+        </p:spPr>
+        <p:style>
+          <a:lnRef idx="1">
+            <a:schemeClr val="accent1"/>
+          </a:lnRef>
+          <a:fillRef idx="3">
+            <a:schemeClr val="accent1"/>
+          </a:fillRef>
+          <a:effectRef idx="2">
+            <a:schemeClr val="accent1"/>
+          </a:effectRef>
+          <a:fontRef idx="minor">
+            <a:schemeClr val="lt1"/>
+          </a:fontRef>
+        </p:style>
+        <p:txBody>
+          <a:bodyPr rtlCol="0" anchor="ctr"/>
+          <a:lstStyle/>
+          <a:p>
+            <a:pPr algn="ctr"/>
+          </a:p>
+        </p:txBody>
+      </p:sp>
+      <p:sp>
+        <p:nvSpPr>
+          <p:cNvPr id="6" name="TextBox 5"/>
           <p:cNvSpPr txBox="1"/>
           <p:nvPr/>
         </p:nvSpPr>
         <p:spPr>
           <a:xfrm>
-            <a:off x="731520" y="1645920"/>
-            <a:ext cx="10698480" cy="4572000"/>
+            <a:off x="1005840" y="1737360"/>
+            <a:ext cx="10149840" cy="4389120"/>
           </a:xfrm>
           <a:prstGeom prst="rect">
             <a:avLst/>
@@ -4403,9 +5053,9 @@
           <a:p>
             <a:pPr>
               <a:spcBef>
-                <a:spcPts val="1200"/>
+                <a:spcPts val="1400"/>
               </a:spcBef>
-              <a:defRPr sz="1800" b="1">
+              <a:defRPr sz="2100" b="1">
                 <a:solidFill>
                   <a:srgbClr val="60A5FA"/>
                 </a:solidFill>
@@ -4419,9 +5069,9 @@
           <a:p>
             <a:pPr lvl="1">
               <a:spcBef>
-                <a:spcPts val="300"/>
+                <a:spcPts val="400"/>
               </a:spcBef>
-              <a:defRPr sz="1400">
+              <a:defRPr sz="1600">
                 <a:solidFill>
                   <a:srgbClr val="F1F5F9"/>
                 </a:solidFill>
@@ -4443,9 +5093,9 @@
           <a:p>
             <a:pPr>
               <a:spcBef>
-                <a:spcPts val="1200"/>
+                <a:spcPts val="1400"/>
               </a:spcBef>
-              <a:defRPr sz="1800" b="1">
+              <a:defRPr sz="2100" b="1">
                 <a:solidFill>
                   <a:srgbClr val="60A5FA"/>
                 </a:solidFill>
@@ -4459,9 +5109,9 @@
           <a:p>
             <a:pPr lvl="1">
               <a:spcBef>
-                <a:spcPts val="300"/>
+                <a:spcPts val="400"/>
               </a:spcBef>
-              <a:defRPr sz="1400">
+              <a:defRPr sz="1600">
                 <a:solidFill>
                   <a:srgbClr val="F1F5F9"/>
                 </a:solidFill>
@@ -4479,9 +5129,9 @@
           <a:p>
             <a:pPr>
               <a:spcBef>
-                <a:spcPts val="1200"/>
+                <a:spcPts val="1400"/>
               </a:spcBef>
-              <a:defRPr sz="1800" b="1">
+              <a:defRPr sz="2100" b="1">
                 <a:solidFill>
                   <a:srgbClr val="60A5FA"/>
                 </a:solidFill>
@@ -4495,9 +5145,9 @@
           <a:p>
             <a:pPr lvl="1">
               <a:spcBef>
-                <a:spcPts val="300"/>
+                <a:spcPts val="400"/>
               </a:spcBef>
-              <a:defRPr sz="1400">
+              <a:defRPr sz="1600">
                 <a:solidFill>
                   <a:srgbClr val="F1F5F9"/>
                 </a:solidFill>
@@ -4542,13 +5192,58 @@
       <p:grpSpPr/>
       <p:sp>
         <p:nvSpPr>
-          <p:cNvPr id="2" name="TextBox 1"/>
+          <p:cNvPr id="2" name="Rectangle 1"/>
+          <p:cNvSpPr/>
+          <p:nvPr/>
+        </p:nvSpPr>
+        <p:spPr>
+          <a:xfrm>
+            <a:off x="411480" y="365760"/>
+            <a:ext cx="109728" cy="1005840"/>
+          </a:xfrm>
+          <a:prstGeom prst="rect">
+            <a:avLst/>
+          </a:prstGeom>
+          <a:solidFill>
+            <a:srgbClr val="60A5FA"/>
+          </a:solidFill>
+          <a:ln w="12700">
+            <a:solidFill>
+              <a:srgbClr val="60A5FA"/>
+            </a:solidFill>
+          </a:ln>
+        </p:spPr>
+        <p:style>
+          <a:lnRef idx="1">
+            <a:schemeClr val="accent1"/>
+          </a:lnRef>
+          <a:fillRef idx="3">
+            <a:schemeClr val="accent1"/>
+          </a:fillRef>
+          <a:effectRef idx="2">
+            <a:schemeClr val="accent1"/>
+          </a:effectRef>
+          <a:fontRef idx="minor">
+            <a:schemeClr val="lt1"/>
+          </a:fontRef>
+        </p:style>
+        <p:txBody>
+          <a:bodyPr rtlCol="0" anchor="ctr"/>
+          <a:lstStyle/>
+          <a:p>
+            <a:pPr algn="ctr"/>
+          </a:p>
+        </p:txBody>
+      </p:sp>
+      <p:sp>
+        <p:nvSpPr>
+          <p:cNvPr id="3" name="TextBox 2"/>
           <p:cNvSpPr txBox="1"/>
           <p:nvPr/>
         </p:nvSpPr>
         <p:spPr>
           <a:xfrm>
-            <a:off x="731520" y="365760"/>
+            <a:off x="731520" y="320040"/>
             <a:ext cx="10698480" cy="365760"/>
           </a:xfrm>
           <a:prstGeom prst="rect">
@@ -4563,7 +5258,7 @@
           <a:lstStyle/>
           <a:p>
             <a:pPr>
-              <a:defRPr sz="1000" b="1">
+              <a:defRPr sz="1100" b="1">
                 <a:solidFill>
                   <a:srgbClr val="60A5FA"/>
                 </a:solidFill>
@@ -4578,14 +5273,14 @@
       </p:sp>
       <p:sp>
         <p:nvSpPr>
-          <p:cNvPr id="3" name="TextBox 2"/>
+          <p:cNvPr id="4" name="TextBox 3"/>
           <p:cNvSpPr txBox="1"/>
           <p:nvPr/>
         </p:nvSpPr>
         <p:spPr>
           <a:xfrm>
-            <a:off x="731520" y="640080"/>
-            <a:ext cx="10698480" cy="731520"/>
+            <a:off x="731520" y="594360"/>
+            <a:ext cx="10698480" cy="822960"/>
           </a:xfrm>
           <a:prstGeom prst="rect">
             <a:avLst/>
@@ -4599,7 +5294,7 @@
           <a:lstStyle/>
           <a:p>
             <a:pPr>
-              <a:defRPr sz="2800" b="1">
+              <a:defRPr sz="3400" b="1">
                 <a:solidFill>
                   <a:srgbClr val="F1F5F9"/>
                 </a:solidFill>
@@ -4614,14 +5309,59 @@
       </p:sp>
       <p:sp>
         <p:nvSpPr>
-          <p:cNvPr id="4" name="TextBox 3"/>
+          <p:cNvPr id="5" name="Rounded Rectangle 4"/>
+          <p:cNvSpPr/>
+          <p:nvPr/>
+        </p:nvSpPr>
+        <p:spPr>
+          <a:xfrm>
+            <a:off x="731520" y="1554480"/>
+            <a:ext cx="10728655" cy="4754880"/>
+          </a:xfrm>
+          <a:prstGeom prst="roundRect">
+            <a:avLst/>
+          </a:prstGeom>
+          <a:solidFill>
+            <a:srgbClr val="151D2B"/>
+          </a:solidFill>
+          <a:ln w="25400">
+            <a:solidFill>
+              <a:srgbClr val="60A5FA"/>
+            </a:solidFill>
+          </a:ln>
+        </p:spPr>
+        <p:style>
+          <a:lnRef idx="1">
+            <a:schemeClr val="accent1"/>
+          </a:lnRef>
+          <a:fillRef idx="3">
+            <a:schemeClr val="accent1"/>
+          </a:fillRef>
+          <a:effectRef idx="2">
+            <a:schemeClr val="accent1"/>
+          </a:effectRef>
+          <a:fontRef idx="minor">
+            <a:schemeClr val="lt1"/>
+          </a:fontRef>
+        </p:style>
+        <p:txBody>
+          <a:bodyPr rtlCol="0" anchor="ctr"/>
+          <a:lstStyle/>
+          <a:p>
+            <a:pPr algn="ctr"/>
+          </a:p>
+        </p:txBody>
+      </p:sp>
+      <p:sp>
+        <p:nvSpPr>
+          <p:cNvPr id="6" name="TextBox 5"/>
           <p:cNvSpPr txBox="1"/>
           <p:nvPr/>
         </p:nvSpPr>
         <p:spPr>
           <a:xfrm>
-            <a:off x="731520" y="1645920"/>
-            <a:ext cx="10698480" cy="4572000"/>
+            <a:off x="1005840" y="1737360"/>
+            <a:ext cx="10149840" cy="4389120"/>
           </a:xfrm>
           <a:prstGeom prst="rect">
             <a:avLst/>
@@ -4636,9 +5376,9 @@
           <a:p>
             <a:pPr>
               <a:spcBef>
-                <a:spcPts val="1200"/>
+                <a:spcPts val="1400"/>
               </a:spcBef>
-              <a:defRPr sz="1800" b="1">
+              <a:defRPr sz="2100" b="1">
                 <a:solidFill>
                   <a:srgbClr val="60A5FA"/>
                 </a:solidFill>
@@ -4652,9 +5392,9 @@
           <a:p>
             <a:pPr lvl="1">
               <a:spcBef>
-                <a:spcPts val="300"/>
+                <a:spcPts val="400"/>
               </a:spcBef>
-              <a:defRPr sz="1400">
+              <a:defRPr sz="1600">
                 <a:solidFill>
                   <a:srgbClr val="F1F5F9"/>
                 </a:solidFill>
@@ -4672,9 +5412,9 @@
           <a:p>
             <a:pPr>
               <a:spcBef>
-                <a:spcPts val="1200"/>
+                <a:spcPts val="1400"/>
               </a:spcBef>
-              <a:defRPr sz="1800" b="1">
+              <a:defRPr sz="2100" b="1">
                 <a:solidFill>
                   <a:srgbClr val="60A5FA"/>
                 </a:solidFill>
@@ -4688,9 +5428,9 @@
           <a:p>
             <a:pPr lvl="1">
               <a:spcBef>
-                <a:spcPts val="300"/>
+                <a:spcPts val="400"/>
               </a:spcBef>
-              <a:defRPr sz="1400">
+              <a:defRPr sz="1600">
                 <a:solidFill>
                   <a:srgbClr val="F1F5F9"/>
                 </a:solidFill>
@@ -4708,9 +5448,9 @@
           <a:p>
             <a:pPr>
               <a:spcBef>
-                <a:spcPts val="1200"/>
+                <a:spcPts val="1400"/>
               </a:spcBef>
-              <a:defRPr sz="1800" b="1">
+              <a:defRPr sz="2100" b="1">
                 <a:solidFill>
                   <a:srgbClr val="60A5FA"/>
                 </a:solidFill>
@@ -4724,9 +5464,9 @@
           <a:p>
             <a:pPr lvl="1">
               <a:spcBef>
-                <a:spcPts val="300"/>
+                <a:spcPts val="400"/>
               </a:spcBef>
-              <a:defRPr sz="1400">
+              <a:defRPr sz="1600">
                 <a:solidFill>
                   <a:srgbClr val="F1F5F9"/>
                 </a:solidFill>
@@ -4771,13 +5511,58 @@
       <p:grpSpPr/>
       <p:sp>
         <p:nvSpPr>
-          <p:cNvPr id="2" name="TextBox 1"/>
+          <p:cNvPr id="2" name="Rectangle 1"/>
+          <p:cNvSpPr/>
+          <p:nvPr/>
+        </p:nvSpPr>
+        <p:spPr>
+          <a:xfrm>
+            <a:off x="411480" y="365760"/>
+            <a:ext cx="109728" cy="1005840"/>
+          </a:xfrm>
+          <a:prstGeom prst="rect">
+            <a:avLst/>
+          </a:prstGeom>
+          <a:solidFill>
+            <a:srgbClr val="60A5FA"/>
+          </a:solidFill>
+          <a:ln w="12700">
+            <a:solidFill>
+              <a:srgbClr val="60A5FA"/>
+            </a:solidFill>
+          </a:ln>
+        </p:spPr>
+        <p:style>
+          <a:lnRef idx="1">
+            <a:schemeClr val="accent1"/>
+          </a:lnRef>
+          <a:fillRef idx="3">
+            <a:schemeClr val="accent1"/>
+          </a:fillRef>
+          <a:effectRef idx="2">
+            <a:schemeClr val="accent1"/>
+          </a:effectRef>
+          <a:fontRef idx="minor">
+            <a:schemeClr val="lt1"/>
+          </a:fontRef>
+        </p:style>
+        <p:txBody>
+          <a:bodyPr rtlCol="0" anchor="ctr"/>
+          <a:lstStyle/>
+          <a:p>
+            <a:pPr algn="ctr"/>
+          </a:p>
+        </p:txBody>
+      </p:sp>
+      <p:sp>
+        <p:nvSpPr>
+          <p:cNvPr id="3" name="TextBox 2"/>
           <p:cNvSpPr txBox="1"/>
           <p:nvPr/>
         </p:nvSpPr>
         <p:spPr>
           <a:xfrm>
-            <a:off x="731520" y="365760"/>
+            <a:off x="731520" y="320040"/>
             <a:ext cx="10698480" cy="365760"/>
           </a:xfrm>
           <a:prstGeom prst="rect">
@@ -4792,7 +5577,7 @@
           <a:lstStyle/>
           <a:p>
             <a:pPr>
-              <a:defRPr sz="1000" b="1">
+              <a:defRPr sz="1100" b="1">
                 <a:solidFill>
                   <a:srgbClr val="60A5FA"/>
                 </a:solidFill>
@@ -4807,14 +5592,14 @@
       </p:sp>
       <p:sp>
         <p:nvSpPr>
-          <p:cNvPr id="3" name="TextBox 2"/>
+          <p:cNvPr id="4" name="TextBox 3"/>
           <p:cNvSpPr txBox="1"/>
           <p:nvPr/>
         </p:nvSpPr>
         <p:spPr>
           <a:xfrm>
-            <a:off x="731520" y="640080"/>
-            <a:ext cx="10698480" cy="731520"/>
+            <a:off x="731520" y="594360"/>
+            <a:ext cx="10698480" cy="822960"/>
           </a:xfrm>
           <a:prstGeom prst="rect">
             <a:avLst/>
@@ -4828,7 +5613,7 @@
           <a:lstStyle/>
           <a:p>
             <a:pPr>
-              <a:defRPr sz="2800" b="1">
+              <a:defRPr sz="3400" b="1">
                 <a:solidFill>
                   <a:srgbClr val="F1F5F9"/>
                 </a:solidFill>
@@ -4843,14 +5628,59 @@
       </p:sp>
       <p:sp>
         <p:nvSpPr>
-          <p:cNvPr id="4" name="TextBox 3"/>
+          <p:cNvPr id="5" name="Rounded Rectangle 4"/>
+          <p:cNvSpPr/>
+          <p:nvPr/>
+        </p:nvSpPr>
+        <p:spPr>
+          <a:xfrm>
+            <a:off x="731520" y="1554480"/>
+            <a:ext cx="10728655" cy="4754880"/>
+          </a:xfrm>
+          <a:prstGeom prst="roundRect">
+            <a:avLst/>
+          </a:prstGeom>
+          <a:solidFill>
+            <a:srgbClr val="151D2B"/>
+          </a:solidFill>
+          <a:ln w="25400">
+            <a:solidFill>
+              <a:srgbClr val="10B981"/>
+            </a:solidFill>
+          </a:ln>
+        </p:spPr>
+        <p:style>
+          <a:lnRef idx="1">
+            <a:schemeClr val="accent1"/>
+          </a:lnRef>
+          <a:fillRef idx="3">
+            <a:schemeClr val="accent1"/>
+          </a:fillRef>
+          <a:effectRef idx="2">
+            <a:schemeClr val="accent1"/>
+          </a:effectRef>
+          <a:fontRef idx="minor">
+            <a:schemeClr val="lt1"/>
+          </a:fontRef>
+        </p:style>
+        <p:txBody>
+          <a:bodyPr rtlCol="0" anchor="ctr"/>
+          <a:lstStyle/>
+          <a:p>
+            <a:pPr algn="ctr"/>
+          </a:p>
+        </p:txBody>
+      </p:sp>
+      <p:sp>
+        <p:nvSpPr>
+          <p:cNvPr id="6" name="TextBox 5"/>
           <p:cNvSpPr txBox="1"/>
           <p:nvPr/>
         </p:nvSpPr>
         <p:spPr>
           <a:xfrm>
-            <a:off x="731520" y="1645920"/>
-            <a:ext cx="10698480" cy="4572000"/>
+            <a:off x="1005840" y="1737360"/>
+            <a:ext cx="10149840" cy="4389120"/>
           </a:xfrm>
           <a:prstGeom prst="rect">
             <a:avLst/>
@@ -4865,9 +5695,9 @@
           <a:p>
             <a:pPr>
               <a:spcBef>
-                <a:spcPts val="1200"/>
+                <a:spcPts val="1400"/>
               </a:spcBef>
-              <a:defRPr sz="1800" b="1">
+              <a:defRPr sz="2100" b="1">
                 <a:solidFill>
                   <a:srgbClr val="60A5FA"/>
                 </a:solidFill>
@@ -4881,9 +5711,9 @@
           <a:p>
             <a:pPr lvl="1">
               <a:spcBef>
-                <a:spcPts val="300"/>
+                <a:spcPts val="400"/>
               </a:spcBef>
-              <a:defRPr sz="1400">
+              <a:defRPr sz="1600">
                 <a:solidFill>
                   <a:srgbClr val="F1F5F9"/>
                 </a:solidFill>
@@ -4897,9 +5727,9 @@
           <a:p>
             <a:pPr>
               <a:spcBef>
-                <a:spcPts val="1200"/>
+                <a:spcPts val="1400"/>
               </a:spcBef>
-              <a:defRPr sz="1800" b="1">
+              <a:defRPr sz="2100" b="1">
                 <a:solidFill>
                   <a:srgbClr val="60A5FA"/>
                 </a:solidFill>
@@ -4913,9 +5743,9 @@
           <a:p>
             <a:pPr lvl="1">
               <a:spcBef>
-                <a:spcPts val="300"/>
+                <a:spcPts val="400"/>
               </a:spcBef>
-              <a:defRPr sz="1400">
+              <a:defRPr sz="1600">
                 <a:solidFill>
                   <a:srgbClr val="F1F5F9"/>
                 </a:solidFill>
@@ -4933,9 +5763,9 @@
           <a:p>
             <a:pPr>
               <a:spcBef>
-                <a:spcPts val="1200"/>
+                <a:spcPts val="1400"/>
               </a:spcBef>
-              <a:defRPr sz="1800" b="1">
+              <a:defRPr sz="2100" b="1">
                 <a:solidFill>
                   <a:srgbClr val="60A5FA"/>
                 </a:solidFill>
@@ -4949,9 +5779,9 @@
           <a:p>
             <a:pPr lvl="1">
               <a:spcBef>
-                <a:spcPts val="300"/>
+                <a:spcPts val="400"/>
               </a:spcBef>
-              <a:defRPr sz="1400">
+              <a:defRPr sz="1600">
                 <a:solidFill>
                   <a:srgbClr val="F1F5F9"/>
                 </a:solidFill>

</xml_diff>